<commit_message>
Added EDA visualizations and update presentation
</commit_message>
<xml_diff>
--- a/SyriaTel Customer Churn Analysis.pptx
+++ b/SyriaTel Customer Churn Analysis.pptx
@@ -9,11 +9,13 @@
     <p:sldId id="257" r:id="rId3"/>
     <p:sldId id="258" r:id="rId4"/>
     <p:sldId id="259" r:id="rId5"/>
-    <p:sldId id="260" r:id="rId6"/>
-    <p:sldId id="261" r:id="rId7"/>
-    <p:sldId id="263" r:id="rId8"/>
-    <p:sldId id="264" r:id="rId9"/>
-    <p:sldId id="266" r:id="rId10"/>
+    <p:sldId id="268" r:id="rId6"/>
+    <p:sldId id="269" r:id="rId7"/>
+    <p:sldId id="260" r:id="rId8"/>
+    <p:sldId id="261" r:id="rId9"/>
+    <p:sldId id="263" r:id="rId10"/>
+    <p:sldId id="264" r:id="rId11"/>
+    <p:sldId id="266" r:id="rId12"/>
   </p:sldIdLst>
   <p:sldSz cx="12192000" cy="6858000"/>
   <p:notesSz cx="6858000" cy="9144000"/>
@@ -113,6 +115,105 @@
     </a:lvl9pPr>
   </p:defaultTextStyle>
 </p:presentation>
+</file>
+
+<file path=ppt/changesInfos/changesInfo1.xml><?xml version="1.0" encoding="utf-8"?>
+<pc:chgInfo xmlns:a="http://schemas.openxmlformats.org/drawingml/2006/main" xmlns:r="http://schemas.openxmlformats.org/officeDocument/2006/relationships" xmlns:ac="http://schemas.microsoft.com/office/drawing/2013/main/command" xmlns:pc="http://schemas.microsoft.com/office/powerpoint/2013/main/command">
+  <pc:docChgLst>
+    <pc:chgData name="Keith Njihia" userId="1e99fe23f231bfb1" providerId="LiveId" clId="{3A04604A-EEBB-4A6F-99F6-790ED387411E}"/>
+    <pc:docChg chg="addSld delSld modSld">
+      <pc:chgData name="Keith Njihia" userId="1e99fe23f231bfb1" providerId="LiveId" clId="{3A04604A-EEBB-4A6F-99F6-790ED387411E}" dt="2026-05-04T14:50:20.893" v="60" actId="14100"/>
+      <pc:docMkLst>
+        <pc:docMk/>
+      </pc:docMkLst>
+      <pc:sldChg chg="new del">
+        <pc:chgData name="Keith Njihia" userId="1e99fe23f231bfb1" providerId="LiveId" clId="{3A04604A-EEBB-4A6F-99F6-790ED387411E}" dt="2026-05-03T19:26:53.917" v="29" actId="2696"/>
+        <pc:sldMkLst>
+          <pc:docMk/>
+          <pc:sldMk cId="3042223956" sldId="267"/>
+        </pc:sldMkLst>
+      </pc:sldChg>
+      <pc:sldChg chg="addSp delSp modSp new mod">
+        <pc:chgData name="Keith Njihia" userId="1e99fe23f231bfb1" providerId="LiveId" clId="{3A04604A-EEBB-4A6F-99F6-790ED387411E}" dt="2026-05-03T19:26:42.383" v="28" actId="255"/>
+        <pc:sldMkLst>
+          <pc:docMk/>
+          <pc:sldMk cId="2035054528" sldId="268"/>
+        </pc:sldMkLst>
+        <pc:spChg chg="mod">
+          <ac:chgData name="Keith Njihia" userId="1e99fe23f231bfb1" providerId="LiveId" clId="{3A04604A-EEBB-4A6F-99F6-790ED387411E}" dt="2026-05-03T19:24:36.242" v="26" actId="20577"/>
+          <ac:spMkLst>
+            <pc:docMk/>
+            <pc:sldMk cId="2035054528" sldId="268"/>
+            <ac:spMk id="2" creationId="{88B47FAE-4899-D85B-FC8F-BA6B3520BB4F}"/>
+          </ac:spMkLst>
+        </pc:spChg>
+        <pc:spChg chg="del">
+          <ac:chgData name="Keith Njihia" userId="1e99fe23f231bfb1" providerId="LiveId" clId="{3A04604A-EEBB-4A6F-99F6-790ED387411E}" dt="2026-05-03T19:23:20.880" v="2" actId="931"/>
+          <ac:spMkLst>
+            <pc:docMk/>
+            <pc:sldMk cId="2035054528" sldId="268"/>
+            <ac:spMk id="3" creationId="{9C256FE3-261F-8BEC-9143-7A67BAAE4B98}"/>
+          </ac:spMkLst>
+        </pc:spChg>
+        <pc:spChg chg="mod">
+          <ac:chgData name="Keith Njihia" userId="1e99fe23f231bfb1" providerId="LiveId" clId="{3A04604A-EEBB-4A6F-99F6-790ED387411E}" dt="2026-05-03T19:26:42.383" v="28" actId="255"/>
+          <ac:spMkLst>
+            <pc:docMk/>
+            <pc:sldMk cId="2035054528" sldId="268"/>
+            <ac:spMk id="4" creationId="{FFCA16F8-8757-107E-DACD-079EAB68552F}"/>
+          </ac:spMkLst>
+        </pc:spChg>
+        <pc:picChg chg="add mod ord">
+          <ac:chgData name="Keith Njihia" userId="1e99fe23f231bfb1" providerId="LiveId" clId="{3A04604A-EEBB-4A6F-99F6-790ED387411E}" dt="2026-05-03T19:23:42.195" v="6" actId="1076"/>
+          <ac:picMkLst>
+            <pc:docMk/>
+            <pc:sldMk cId="2035054528" sldId="268"/>
+            <ac:picMk id="6" creationId="{730D1528-AA25-B315-ACE0-87F6CF5BCC62}"/>
+          </ac:picMkLst>
+        </pc:picChg>
+      </pc:sldChg>
+      <pc:sldChg chg="addSp delSp modSp new mod">
+        <pc:chgData name="Keith Njihia" userId="1e99fe23f231bfb1" providerId="LiveId" clId="{3A04604A-EEBB-4A6F-99F6-790ED387411E}" dt="2026-05-04T14:50:20.893" v="60" actId="14100"/>
+        <pc:sldMkLst>
+          <pc:docMk/>
+          <pc:sldMk cId="3537947912" sldId="269"/>
+        </pc:sldMkLst>
+        <pc:spChg chg="mod">
+          <ac:chgData name="Keith Njihia" userId="1e99fe23f231bfb1" providerId="LiveId" clId="{3A04604A-EEBB-4A6F-99F6-790ED387411E}" dt="2026-05-04T14:48:13.985" v="51" actId="20577"/>
+          <ac:spMkLst>
+            <pc:docMk/>
+            <pc:sldMk cId="3537947912" sldId="269"/>
+            <ac:spMk id="2" creationId="{77AA07ED-B312-7096-53A7-7656CF82BF26}"/>
+          </ac:spMkLst>
+        </pc:spChg>
+        <pc:spChg chg="del">
+          <ac:chgData name="Keith Njihia" userId="1e99fe23f231bfb1" providerId="LiveId" clId="{3A04604A-EEBB-4A6F-99F6-790ED387411E}" dt="2026-05-04T14:49:50.840" v="54" actId="931"/>
+          <ac:spMkLst>
+            <pc:docMk/>
+            <pc:sldMk cId="3537947912" sldId="269"/>
+            <ac:spMk id="3" creationId="{C1BC9BFD-7A2F-40D4-D178-42153DA18CC4}"/>
+          </ac:spMkLst>
+        </pc:spChg>
+        <pc:spChg chg="mod">
+          <ac:chgData name="Keith Njihia" userId="1e99fe23f231bfb1" providerId="LiveId" clId="{3A04604A-EEBB-4A6F-99F6-790ED387411E}" dt="2026-05-04T14:49:31.438" v="53"/>
+          <ac:spMkLst>
+            <pc:docMk/>
+            <pc:sldMk cId="3537947912" sldId="269"/>
+            <ac:spMk id="4" creationId="{67BE4FC2-1F90-6AE5-C765-503DEF99A078}"/>
+          </ac:spMkLst>
+        </pc:spChg>
+        <pc:picChg chg="add mod ord">
+          <ac:chgData name="Keith Njihia" userId="1e99fe23f231bfb1" providerId="LiveId" clId="{3A04604A-EEBB-4A6F-99F6-790ED387411E}" dt="2026-05-04T14:50:20.893" v="60" actId="14100"/>
+          <ac:picMkLst>
+            <pc:docMk/>
+            <pc:sldMk cId="3537947912" sldId="269"/>
+            <ac:picMk id="6" creationId="{6E2A2413-F29D-364B-CD75-DF2367A6B65D}"/>
+          </ac:picMkLst>
+        </pc:picChg>
+      </pc:sldChg>
+    </pc:docChg>
+  </pc:docChgLst>
+</pc:chgInfo>
 </file>
 
 <file path=ppt/slideLayouts/slideLayout1.xml><?xml version="1.0" encoding="utf-8"?>
@@ -3411,6 +3512,193 @@
 </p:sld>
 </file>
 
+<file path=ppt/slides/slide10.xml><?xml version="1.0" encoding="utf-8"?>
+<p:sld xmlns:a="http://schemas.openxmlformats.org/drawingml/2006/main" xmlns:r="http://schemas.openxmlformats.org/officeDocument/2006/relationships" xmlns:p="http://schemas.openxmlformats.org/presentationml/2006/main">
+  <p:cSld>
+    <p:spTree>
+      <p:nvGrpSpPr>
+        <p:cNvPr id="1" name=""/>
+        <p:cNvGrpSpPr/>
+        <p:nvPr/>
+      </p:nvGrpSpPr>
+      <p:grpSpPr>
+        <a:xfrm>
+          <a:off x="0" y="0"/>
+          <a:ext cx="0" cy="0"/>
+          <a:chOff x="0" y="0"/>
+          <a:chExt cx="0" cy="0"/>
+        </a:xfrm>
+      </p:grpSpPr>
+      <p:sp>
+        <p:nvSpPr>
+          <p:cNvPr id="2" name="Title 1">
+            <a:extLst>
+              <a:ext uri="{FF2B5EF4-FFF2-40B4-BE49-F238E27FC236}">
+                <a16:creationId xmlns:a16="http://schemas.microsoft.com/office/drawing/2014/main" id="{CAB057C7-23FB-0F79-C7CB-6589B66E5FE8}"/>
+              </a:ext>
+            </a:extLst>
+          </p:cNvPr>
+          <p:cNvSpPr>
+            <a:spLocks noGrp="1"/>
+          </p:cNvSpPr>
+          <p:nvPr>
+            <p:ph type="title"/>
+          </p:nvPr>
+        </p:nvSpPr>
+        <p:spPr/>
+        <p:txBody>
+          <a:bodyPr/>
+          <a:lstStyle/>
+          <a:p>
+            <a:r>
+              <a:rPr lang="en-US" b="1" i="1" dirty="0"/>
+              <a:t>Next Steps </a:t>
+            </a:r>
+          </a:p>
+        </p:txBody>
+      </p:sp>
+      <p:sp>
+        <p:nvSpPr>
+          <p:cNvPr id="3" name="Content Placeholder 2">
+            <a:extLst>
+              <a:ext uri="{FF2B5EF4-FFF2-40B4-BE49-F238E27FC236}">
+                <a16:creationId xmlns:a16="http://schemas.microsoft.com/office/drawing/2014/main" id="{371EDAA6-47E5-BB0A-D4AA-FFD32B4571D9}"/>
+              </a:ext>
+            </a:extLst>
+          </p:cNvPr>
+          <p:cNvSpPr>
+            <a:spLocks noGrp="1"/>
+          </p:cNvSpPr>
+          <p:nvPr>
+            <p:ph idx="1"/>
+          </p:nvPr>
+        </p:nvSpPr>
+        <p:spPr/>
+        <p:txBody>
+          <a:bodyPr/>
+          <a:lstStyle/>
+          <a:p>
+            <a:r>
+              <a:rPr lang="en-US" dirty="0"/>
+              <a:t>Try Random Forest for better performance</a:t>
+            </a:r>
+          </a:p>
+          <a:p>
+            <a:endParaRPr lang="en-US" dirty="0"/>
+          </a:p>
+          <a:p>
+            <a:r>
+              <a:rPr lang="en-US" dirty="0"/>
+              <a:t>Address class imbalance using SMOTE</a:t>
+            </a:r>
+          </a:p>
+          <a:p>
+            <a:endParaRPr lang="en-US" dirty="0"/>
+          </a:p>
+          <a:p>
+            <a:r>
+              <a:rPr lang="en-US" dirty="0"/>
+              <a:t>Monitor model performance over time</a:t>
+            </a:r>
+          </a:p>
+        </p:txBody>
+      </p:sp>
+    </p:spTree>
+    <p:extLst>
+      <p:ext uri="{BB962C8B-B14F-4D97-AF65-F5344CB8AC3E}">
+        <p14:creationId xmlns:p14="http://schemas.microsoft.com/office/powerpoint/2010/main" val="1127909777"/>
+      </p:ext>
+    </p:extLst>
+  </p:cSld>
+  <p:clrMapOvr>
+    <a:masterClrMapping/>
+  </p:clrMapOvr>
+</p:sld>
+</file>
+
+<file path=ppt/slides/slide11.xml><?xml version="1.0" encoding="utf-8"?>
+<p:sld xmlns:a="http://schemas.openxmlformats.org/drawingml/2006/main" xmlns:r="http://schemas.openxmlformats.org/officeDocument/2006/relationships" xmlns:p="http://schemas.openxmlformats.org/presentationml/2006/main">
+  <p:cSld>
+    <p:spTree>
+      <p:nvGrpSpPr>
+        <p:cNvPr id="1" name=""/>
+        <p:cNvGrpSpPr/>
+        <p:nvPr/>
+      </p:nvGrpSpPr>
+      <p:grpSpPr>
+        <a:xfrm>
+          <a:off x="0" y="0"/>
+          <a:ext cx="0" cy="0"/>
+          <a:chOff x="0" y="0"/>
+          <a:chExt cx="0" cy="0"/>
+        </a:xfrm>
+      </p:grpSpPr>
+      <p:sp>
+        <p:nvSpPr>
+          <p:cNvPr id="2" name="Title 1">
+            <a:extLst>
+              <a:ext uri="{FF2B5EF4-FFF2-40B4-BE49-F238E27FC236}">
+                <a16:creationId xmlns:a16="http://schemas.microsoft.com/office/drawing/2014/main" id="{4556B96D-9BF6-3F9E-C62C-8B7216017D4D}"/>
+              </a:ext>
+            </a:extLst>
+          </p:cNvPr>
+          <p:cNvSpPr>
+            <a:spLocks noGrp="1"/>
+          </p:cNvSpPr>
+          <p:nvPr>
+            <p:ph type="ctrTitle"/>
+          </p:nvPr>
+        </p:nvSpPr>
+        <p:spPr/>
+        <p:txBody>
+          <a:bodyPr/>
+          <a:lstStyle/>
+          <a:p>
+            <a:r>
+              <a:rPr lang="en-US" b="1" i="1" u="sng" dirty="0"/>
+              <a:t>Thank you</a:t>
+            </a:r>
+          </a:p>
+        </p:txBody>
+      </p:sp>
+      <p:sp>
+        <p:nvSpPr>
+          <p:cNvPr id="3" name="Subtitle 2">
+            <a:extLst>
+              <a:ext uri="{FF2B5EF4-FFF2-40B4-BE49-F238E27FC236}">
+                <a16:creationId xmlns:a16="http://schemas.microsoft.com/office/drawing/2014/main" id="{608A66A3-F120-D367-8766-E56475B9C34F}"/>
+              </a:ext>
+            </a:extLst>
+          </p:cNvPr>
+          <p:cNvSpPr>
+            <a:spLocks noGrp="1"/>
+          </p:cNvSpPr>
+          <p:nvPr>
+            <p:ph type="subTitle" idx="1"/>
+          </p:nvPr>
+        </p:nvSpPr>
+        <p:spPr/>
+        <p:txBody>
+          <a:bodyPr/>
+          <a:lstStyle/>
+          <a:p>
+            <a:endParaRPr lang="en-US" dirty="0"/>
+          </a:p>
+        </p:txBody>
+      </p:sp>
+    </p:spTree>
+    <p:extLst>
+      <p:ext uri="{BB962C8B-B14F-4D97-AF65-F5344CB8AC3E}">
+        <p14:creationId xmlns:p14="http://schemas.microsoft.com/office/powerpoint/2010/main" val="2052507320"/>
+      </p:ext>
+    </p:extLst>
+  </p:cSld>
+  <p:clrMapOvr>
+    <a:masterClrMapping/>
+  </p:clrMapOvr>
+</p:sld>
+</file>
+
 <file path=ppt/slides/slide2.xml><?xml version="1.0" encoding="utf-8"?>
 <p:sld xmlns:a="http://schemas.openxmlformats.org/drawingml/2006/main" xmlns:r="http://schemas.openxmlformats.org/officeDocument/2006/relationships" xmlns:p="http://schemas.openxmlformats.org/presentationml/2006/main">
   <p:cSld>
@@ -3745,7 +4033,7 @@
           <p:cNvPr id="2" name="Title 1">
             <a:extLst>
               <a:ext uri="{FF2B5EF4-FFF2-40B4-BE49-F238E27FC236}">
-                <a16:creationId xmlns:a16="http://schemas.microsoft.com/office/drawing/2014/main" id="{08ACE4A6-935D-237F-6BF0-508437006B0E}"/>
+                <a16:creationId xmlns:a16="http://schemas.microsoft.com/office/drawing/2014/main" id="{88B47FAE-4899-D85B-FC8F-BA6B3520BB4F}"/>
               </a:ext>
             </a:extLst>
           </p:cNvPr>
@@ -3763,62 +4051,76 @@
           <a:p>
             <a:r>
               <a:rPr lang="en-US" b="1" i="1" dirty="0"/>
-              <a:t>Our Approach</a:t>
-            </a:r>
-          </a:p>
-        </p:txBody>
-      </p:sp>
-      <p:sp>
-        <p:nvSpPr>
-          <p:cNvPr id="3" name="Content Placeholder 2">
-            <a:extLst>
-              <a:ext uri="{FF2B5EF4-FFF2-40B4-BE49-F238E27FC236}">
-                <a16:creationId xmlns:a16="http://schemas.microsoft.com/office/drawing/2014/main" id="{FD8405C8-D7F8-0FEA-4E54-258C44417E82}"/>
-              </a:ext>
-            </a:extLst>
-          </p:cNvPr>
-          <p:cNvSpPr>
-            <a:spLocks noGrp="1"/>
-          </p:cNvSpPr>
-          <p:nvPr>
-            <p:ph idx="1"/>
-          </p:nvPr>
-        </p:nvSpPr>
-        <p:spPr/>
-        <p:txBody>
-          <a:bodyPr/>
-          <a:lstStyle/>
-          <a:p>
-            <a:r>
-              <a:rPr lang="en-US" dirty="0"/>
-              <a:t>Built 3 models iteratively</a:t>
-            </a:r>
-          </a:p>
-          <a:p>
-            <a:endParaRPr lang="en-US" dirty="0"/>
-          </a:p>
-          <a:p>
-            <a:r>
-              <a:rPr lang="en-US" dirty="0"/>
-              <a:t>Model 1: Logistic Regression(baseline)</a:t>
-            </a:r>
-          </a:p>
-          <a:p>
-            <a:endParaRPr lang="en-US" dirty="0"/>
-          </a:p>
-          <a:p>
-            <a:r>
-              <a:rPr lang="en-US" dirty="0"/>
-              <a:t>Model 2: Decision Tree </a:t>
-            </a:r>
-          </a:p>
-          <a:p>
-            <a:endParaRPr lang="en-US" dirty="0"/>
-          </a:p>
-          <a:p>
-            <a:r>
-              <a:rPr lang="en-US" dirty="0"/>
-              <a:t>Model 3 : Tuned Decision Tree (final model)</a:t>
+              <a:t>Churn Distribution</a:t>
+            </a:r>
+          </a:p>
+        </p:txBody>
+      </p:sp>
+      <p:pic>
+        <p:nvPicPr>
+          <p:cNvPr id="6" name="Picture Placeholder 5">
+            <a:extLst>
+              <a:ext uri="{FF2B5EF4-FFF2-40B4-BE49-F238E27FC236}">
+                <a16:creationId xmlns:a16="http://schemas.microsoft.com/office/drawing/2014/main" id="{730D1528-AA25-B315-ACE0-87F6CF5BCC62}"/>
+              </a:ext>
+            </a:extLst>
+          </p:cNvPr>
+          <p:cNvPicPr>
+            <a:picLocks noGrp="1" noChangeAspect="1"/>
+          </p:cNvPicPr>
+          <p:nvPr>
+            <p:ph type="pic" idx="1"/>
+          </p:nvPr>
+        </p:nvPicPr>
+        <p:blipFill>
+          <a:blip r:embed="rId2">
+            <a:extLst>
+              <a:ext uri="{28A0092B-C50C-407E-A947-70E740481C1C}">
+                <a14:useLocalDpi xmlns:a14="http://schemas.microsoft.com/office/drawing/2010/main" val="0"/>
+              </a:ext>
+            </a:extLst>
+          </a:blip>
+          <a:srcRect l="2869" r="2869"/>
+          <a:stretch>
+            <a:fillRect/>
+          </a:stretch>
+        </p:blipFill>
+        <p:spPr>
+          <a:xfrm>
+            <a:off x="4870347" y="825397"/>
+            <a:ext cx="6594662" cy="5207205"/>
+          </a:xfrm>
+          <a:prstGeom prst="rect">
+            <a:avLst/>
+          </a:prstGeom>
+        </p:spPr>
+      </p:pic>
+      <p:sp>
+        <p:nvSpPr>
+          <p:cNvPr id="4" name="Text Placeholder 3">
+            <a:extLst>
+              <a:ext uri="{FF2B5EF4-FFF2-40B4-BE49-F238E27FC236}">
+                <a16:creationId xmlns:a16="http://schemas.microsoft.com/office/drawing/2014/main" id="{FFCA16F8-8757-107E-DACD-079EAB68552F}"/>
+              </a:ext>
+            </a:extLst>
+          </p:cNvPr>
+          <p:cNvSpPr>
+            <a:spLocks noGrp="1"/>
+          </p:cNvSpPr>
+          <p:nvPr>
+            <p:ph type="body" sz="half" idx="2"/>
+          </p:nvPr>
+        </p:nvSpPr>
+        <p:spPr/>
+        <p:txBody>
+          <a:bodyPr>
+            <a:normAutofit/>
+          </a:bodyPr>
+          <a:lstStyle/>
+          <a:p>
+            <a:r>
+              <a:rPr lang="en-US" sz="2800" dirty="0"/>
+              <a:t>Only 14.5% of customers churned (483 out of 3,333) — early identification is key to reducing revenue loss</a:t>
             </a:r>
           </a:p>
         </p:txBody>
@@ -3826,7 +4128,7 @@
     </p:spTree>
     <p:extLst>
       <p:ext uri="{BB962C8B-B14F-4D97-AF65-F5344CB8AC3E}">
-        <p14:creationId xmlns:p14="http://schemas.microsoft.com/office/powerpoint/2010/main" val="2012422870"/>
+        <p14:creationId xmlns:p14="http://schemas.microsoft.com/office/powerpoint/2010/main" val="2035054528"/>
       </p:ext>
     </p:extLst>
   </p:cSld>
@@ -3858,7 +4160,7 @@
           <p:cNvPr id="2" name="Title 1">
             <a:extLst>
               <a:ext uri="{FF2B5EF4-FFF2-40B4-BE49-F238E27FC236}">
-                <a16:creationId xmlns:a16="http://schemas.microsoft.com/office/drawing/2014/main" id="{6D729A44-54BF-B884-5F82-854F56268FFD}"/>
+                <a16:creationId xmlns:a16="http://schemas.microsoft.com/office/drawing/2014/main" id="{77AA07ED-B312-7096-53A7-7656CF82BF26}"/>
               </a:ext>
             </a:extLst>
           </p:cNvPr>
@@ -3876,53 +4178,76 @@
           <a:p>
             <a:r>
               <a:rPr lang="en-US" b="1" i="1" dirty="0"/>
-              <a:t>How Well Does It Work?</a:t>
-            </a:r>
-          </a:p>
-        </p:txBody>
-      </p:sp>
-      <p:sp>
-        <p:nvSpPr>
-          <p:cNvPr id="3" name="Content Placeholder 2">
-            <a:extLst>
-              <a:ext uri="{FF2B5EF4-FFF2-40B4-BE49-F238E27FC236}">
-                <a16:creationId xmlns:a16="http://schemas.microsoft.com/office/drawing/2014/main" id="{56D8ED92-85A9-DCC3-EFF8-7B826FB7BEA1}"/>
-              </a:ext>
-            </a:extLst>
-          </p:cNvPr>
-          <p:cNvSpPr>
-            <a:spLocks noGrp="1"/>
-          </p:cNvSpPr>
-          <p:nvPr>
-            <p:ph idx="1"/>
-          </p:nvPr>
-        </p:nvSpPr>
-        <p:spPr/>
-        <p:txBody>
-          <a:bodyPr/>
-          <a:lstStyle/>
-          <a:p>
-            <a:r>
-              <a:rPr lang="en-US" dirty="0"/>
-              <a:t>Our model correctly identifies 94% of cases</a:t>
-            </a:r>
-          </a:p>
-          <a:p>
-            <a:endParaRPr lang="en-US" dirty="0"/>
-          </a:p>
-          <a:p>
-            <a:r>
-              <a:rPr lang="en-US" dirty="0"/>
-              <a:t>When it flags a churner, it is right 88% of the time</a:t>
-            </a:r>
-          </a:p>
-          <a:p>
-            <a:endParaRPr lang="en-US" dirty="0"/>
-          </a:p>
-          <a:p>
-            <a:r>
-              <a:rPr lang="en-US" dirty="0"/>
-              <a:t>Model performs consistently on both training and test data</a:t>
+              <a:t>What Drives Churn ?</a:t>
+            </a:r>
+          </a:p>
+        </p:txBody>
+      </p:sp>
+      <p:pic>
+        <p:nvPicPr>
+          <p:cNvPr id="6" name="Picture Placeholder 5">
+            <a:extLst>
+              <a:ext uri="{FF2B5EF4-FFF2-40B4-BE49-F238E27FC236}">
+                <a16:creationId xmlns:a16="http://schemas.microsoft.com/office/drawing/2014/main" id="{6E2A2413-F29D-364B-CD75-DF2367A6B65D}"/>
+              </a:ext>
+            </a:extLst>
+          </p:cNvPr>
+          <p:cNvPicPr>
+            <a:picLocks noGrp="1" noChangeAspect="1"/>
+          </p:cNvPicPr>
+          <p:nvPr>
+            <p:ph type="pic" idx="1"/>
+          </p:nvPr>
+        </p:nvPicPr>
+        <p:blipFill>
+          <a:blip r:embed="rId2">
+            <a:extLst>
+              <a:ext uri="{28A0092B-C50C-407E-A947-70E740481C1C}">
+                <a14:useLocalDpi xmlns:a14="http://schemas.microsoft.com/office/drawing/2010/main" val="0"/>
+              </a:ext>
+            </a:extLst>
+          </a:blip>
+          <a:srcRect l="3917" r="3917"/>
+          <a:stretch>
+            <a:fillRect/>
+          </a:stretch>
+        </p:blipFill>
+        <p:spPr>
+          <a:xfrm>
+            <a:off x="5368413" y="859606"/>
+            <a:ext cx="6646606" cy="5570691"/>
+          </a:xfrm>
+          <a:prstGeom prst="rect">
+            <a:avLst/>
+          </a:prstGeom>
+        </p:spPr>
+      </p:pic>
+      <p:sp>
+        <p:nvSpPr>
+          <p:cNvPr id="4" name="Text Placeholder 3">
+            <a:extLst>
+              <a:ext uri="{FF2B5EF4-FFF2-40B4-BE49-F238E27FC236}">
+                <a16:creationId xmlns:a16="http://schemas.microsoft.com/office/drawing/2014/main" id="{67BE4FC2-1F90-6AE5-C765-503DEF99A078}"/>
+              </a:ext>
+            </a:extLst>
+          </p:cNvPr>
+          <p:cNvSpPr>
+            <a:spLocks noGrp="1"/>
+          </p:cNvSpPr>
+          <p:nvPr>
+            <p:ph type="body" sz="half" idx="2"/>
+          </p:nvPr>
+        </p:nvSpPr>
+        <p:spPr/>
+        <p:txBody>
+          <a:bodyPr>
+            <a:normAutofit/>
+          </a:bodyPr>
+          <a:lstStyle/>
+          <a:p>
+            <a:r>
+              <a:rPr lang="en-US" sz="2800" dirty="0"/>
+              <a:t>Customers who churned paid significantly higher day charges — targeting these customers early can prevent revenue loss</a:t>
             </a:r>
           </a:p>
         </p:txBody>
@@ -3930,7 +4255,7 @@
     </p:spTree>
     <p:extLst>
       <p:ext uri="{BB962C8B-B14F-4D97-AF65-F5344CB8AC3E}">
-        <p14:creationId xmlns:p14="http://schemas.microsoft.com/office/powerpoint/2010/main" val="870802523"/>
+        <p14:creationId xmlns:p14="http://schemas.microsoft.com/office/powerpoint/2010/main" val="3537947912"/>
       </p:ext>
     </p:extLst>
   </p:cSld>
@@ -3962,7 +4287,7 @@
           <p:cNvPr id="2" name="Title 1">
             <a:extLst>
               <a:ext uri="{FF2B5EF4-FFF2-40B4-BE49-F238E27FC236}">
-                <a16:creationId xmlns:a16="http://schemas.microsoft.com/office/drawing/2014/main" id="{9DE4FD06-EC1A-CD9B-24B1-057F83F73C2A}"/>
+                <a16:creationId xmlns:a16="http://schemas.microsoft.com/office/drawing/2014/main" id="{08ACE4A6-935D-237F-6BF0-508437006B0E}"/>
               </a:ext>
             </a:extLst>
           </p:cNvPr>
@@ -3980,7 +4305,7 @@
           <a:p>
             <a:r>
               <a:rPr lang="en-US" b="1" i="1" dirty="0"/>
-              <a:t>Recommendations </a:t>
+              <a:t>Our Approach</a:t>
             </a:r>
           </a:p>
         </p:txBody>
@@ -3990,7 +4315,7 @@
           <p:cNvPr id="3" name="Content Placeholder 2">
             <a:extLst>
               <a:ext uri="{FF2B5EF4-FFF2-40B4-BE49-F238E27FC236}">
-                <a16:creationId xmlns:a16="http://schemas.microsoft.com/office/drawing/2014/main" id="{E24FDBD6-670E-F6CE-BB50-143CCF5D04AE}"/>
+                <a16:creationId xmlns:a16="http://schemas.microsoft.com/office/drawing/2014/main" id="{FD8405C8-D7F8-0FEA-4E54-258C44417E82}"/>
               </a:ext>
             </a:extLst>
           </p:cNvPr>
@@ -4008,7 +4333,7 @@
           <a:p>
             <a:r>
               <a:rPr lang="en-US" dirty="0"/>
-              <a:t>Deploy the model to flag at-risk customers automatically</a:t>
+              <a:t>Built 3 models iteratively</a:t>
             </a:r>
           </a:p>
           <a:p>
@@ -4017,7 +4342,7 @@
           <a:p>
             <a:r>
               <a:rPr lang="en-US" dirty="0"/>
-              <a:t>Focus retention efforts on high day charge customers</a:t>
+              <a:t>Model 1: Logistic Regression(baseline)</a:t>
             </a:r>
           </a:p>
           <a:p>
@@ -4026,7 +4351,16 @@
           <a:p>
             <a:r>
               <a:rPr lang="en-US" dirty="0"/>
-              <a:t>Offer discounts or upgrades to flagged customers</a:t>
+              <a:t>Model 2: Decision Tree </a:t>
+            </a:r>
+          </a:p>
+          <a:p>
+            <a:endParaRPr lang="en-US" dirty="0"/>
+          </a:p>
+          <a:p>
+            <a:r>
+              <a:rPr lang="en-US" dirty="0"/>
+              <a:t>Model 3 : Tuned Decision Tree (final model)</a:t>
             </a:r>
           </a:p>
         </p:txBody>
@@ -4034,7 +4368,7 @@
     </p:spTree>
     <p:extLst>
       <p:ext uri="{BB962C8B-B14F-4D97-AF65-F5344CB8AC3E}">
-        <p14:creationId xmlns:p14="http://schemas.microsoft.com/office/powerpoint/2010/main" val="591543114"/>
+        <p14:creationId xmlns:p14="http://schemas.microsoft.com/office/powerpoint/2010/main" val="2012422870"/>
       </p:ext>
     </p:extLst>
   </p:cSld>
@@ -4066,7 +4400,7 @@
           <p:cNvPr id="2" name="Title 1">
             <a:extLst>
               <a:ext uri="{FF2B5EF4-FFF2-40B4-BE49-F238E27FC236}">
-                <a16:creationId xmlns:a16="http://schemas.microsoft.com/office/drawing/2014/main" id="{CAB057C7-23FB-0F79-C7CB-6589B66E5FE8}"/>
+                <a16:creationId xmlns:a16="http://schemas.microsoft.com/office/drawing/2014/main" id="{6D729A44-54BF-B884-5F82-854F56268FFD}"/>
               </a:ext>
             </a:extLst>
           </p:cNvPr>
@@ -4084,7 +4418,7 @@
           <a:p>
             <a:r>
               <a:rPr lang="en-US" b="1" i="1" dirty="0"/>
-              <a:t>Next Steps </a:t>
+              <a:t>How Well Does It Work?</a:t>
             </a:r>
           </a:p>
         </p:txBody>
@@ -4094,7 +4428,7 @@
           <p:cNvPr id="3" name="Content Placeholder 2">
             <a:extLst>
               <a:ext uri="{FF2B5EF4-FFF2-40B4-BE49-F238E27FC236}">
-                <a16:creationId xmlns:a16="http://schemas.microsoft.com/office/drawing/2014/main" id="{371EDAA6-47E5-BB0A-D4AA-FFD32B4571D9}"/>
+                <a16:creationId xmlns:a16="http://schemas.microsoft.com/office/drawing/2014/main" id="{56D8ED92-85A9-DCC3-EFF8-7B826FB7BEA1}"/>
               </a:ext>
             </a:extLst>
           </p:cNvPr>
@@ -4112,7 +4446,7 @@
           <a:p>
             <a:r>
               <a:rPr lang="en-US" dirty="0"/>
-              <a:t>Try Random Forest for better performance</a:t>
+              <a:t>Our model correctly identifies 94% of cases</a:t>
             </a:r>
           </a:p>
           <a:p>
@@ -4121,7 +4455,7 @@
           <a:p>
             <a:r>
               <a:rPr lang="en-US" dirty="0"/>
-              <a:t>Address class imbalance using SMOTE</a:t>
+              <a:t>When it flags a churner, it is right 88% of the time</a:t>
             </a:r>
           </a:p>
           <a:p>
@@ -4130,7 +4464,7 @@
           <a:p>
             <a:r>
               <a:rPr lang="en-US" dirty="0"/>
-              <a:t>Monitor model performance over time</a:t>
+              <a:t>Model performs consistently on both training and test data</a:t>
             </a:r>
           </a:p>
         </p:txBody>
@@ -4138,7 +4472,7 @@
     </p:spTree>
     <p:extLst>
       <p:ext uri="{BB962C8B-B14F-4D97-AF65-F5344CB8AC3E}">
-        <p14:creationId xmlns:p14="http://schemas.microsoft.com/office/powerpoint/2010/main" val="1127909777"/>
+        <p14:creationId xmlns:p14="http://schemas.microsoft.com/office/powerpoint/2010/main" val="870802523"/>
       </p:ext>
     </p:extLst>
   </p:cSld>
@@ -4170,58 +4504,79 @@
           <p:cNvPr id="2" name="Title 1">
             <a:extLst>
               <a:ext uri="{FF2B5EF4-FFF2-40B4-BE49-F238E27FC236}">
-                <a16:creationId xmlns:a16="http://schemas.microsoft.com/office/drawing/2014/main" id="{4556B96D-9BF6-3F9E-C62C-8B7216017D4D}"/>
-              </a:ext>
-            </a:extLst>
-          </p:cNvPr>
-          <p:cNvSpPr>
-            <a:spLocks noGrp="1"/>
-          </p:cNvSpPr>
-          <p:nvPr>
-            <p:ph type="ctrTitle"/>
-          </p:nvPr>
-        </p:nvSpPr>
-        <p:spPr/>
-        <p:txBody>
-          <a:bodyPr/>
-          <a:lstStyle/>
-          <a:p>
-            <a:r>
-              <a:rPr lang="en-US" b="1" i="1" u="sng"/>
-              <a:t>Thank you</a:t>
-            </a:r>
-          </a:p>
-        </p:txBody>
-      </p:sp>
-      <p:sp>
-        <p:nvSpPr>
-          <p:cNvPr id="3" name="Subtitle 2">
-            <a:extLst>
-              <a:ext uri="{FF2B5EF4-FFF2-40B4-BE49-F238E27FC236}">
-                <a16:creationId xmlns:a16="http://schemas.microsoft.com/office/drawing/2014/main" id="{608A66A3-F120-D367-8766-E56475B9C34F}"/>
-              </a:ext>
-            </a:extLst>
-          </p:cNvPr>
-          <p:cNvSpPr>
-            <a:spLocks noGrp="1"/>
-          </p:cNvSpPr>
-          <p:nvPr>
-            <p:ph type="subTitle" idx="1"/>
-          </p:nvPr>
-        </p:nvSpPr>
-        <p:spPr/>
-        <p:txBody>
-          <a:bodyPr/>
-          <a:lstStyle/>
-          <a:p>
-            <a:endParaRPr lang="en-US"/>
+                <a16:creationId xmlns:a16="http://schemas.microsoft.com/office/drawing/2014/main" id="{9DE4FD06-EC1A-CD9B-24B1-057F83F73C2A}"/>
+              </a:ext>
+            </a:extLst>
+          </p:cNvPr>
+          <p:cNvSpPr>
+            <a:spLocks noGrp="1"/>
+          </p:cNvSpPr>
+          <p:nvPr>
+            <p:ph type="title"/>
+          </p:nvPr>
+        </p:nvSpPr>
+        <p:spPr/>
+        <p:txBody>
+          <a:bodyPr/>
+          <a:lstStyle/>
+          <a:p>
+            <a:r>
+              <a:rPr lang="en-US" b="1" i="1" dirty="0"/>
+              <a:t>Recommendations </a:t>
+            </a:r>
+          </a:p>
+        </p:txBody>
+      </p:sp>
+      <p:sp>
+        <p:nvSpPr>
+          <p:cNvPr id="3" name="Content Placeholder 2">
+            <a:extLst>
+              <a:ext uri="{FF2B5EF4-FFF2-40B4-BE49-F238E27FC236}">
+                <a16:creationId xmlns:a16="http://schemas.microsoft.com/office/drawing/2014/main" id="{E24FDBD6-670E-F6CE-BB50-143CCF5D04AE}"/>
+              </a:ext>
+            </a:extLst>
+          </p:cNvPr>
+          <p:cNvSpPr>
+            <a:spLocks noGrp="1"/>
+          </p:cNvSpPr>
+          <p:nvPr>
+            <p:ph idx="1"/>
+          </p:nvPr>
+        </p:nvSpPr>
+        <p:spPr/>
+        <p:txBody>
+          <a:bodyPr/>
+          <a:lstStyle/>
+          <a:p>
+            <a:r>
+              <a:rPr lang="en-US" dirty="0"/>
+              <a:t>Deploy the model to flag at-risk customers automatically</a:t>
+            </a:r>
+          </a:p>
+          <a:p>
+            <a:endParaRPr lang="en-US" dirty="0"/>
+          </a:p>
+          <a:p>
+            <a:r>
+              <a:rPr lang="en-US" dirty="0"/>
+              <a:t>Focus retention efforts on high day charge customers</a:t>
+            </a:r>
+          </a:p>
+          <a:p>
+            <a:endParaRPr lang="en-US" dirty="0"/>
+          </a:p>
+          <a:p>
+            <a:r>
+              <a:rPr lang="en-US" dirty="0"/>
+              <a:t>Offer discounts or upgrades to flagged customers</a:t>
+            </a:r>
           </a:p>
         </p:txBody>
       </p:sp>
     </p:spTree>
     <p:extLst>
       <p:ext uri="{BB962C8B-B14F-4D97-AF65-F5344CB8AC3E}">
-        <p14:creationId xmlns:p14="http://schemas.microsoft.com/office/powerpoint/2010/main" val="2052507320"/>
+        <p14:creationId xmlns:p14="http://schemas.microsoft.com/office/powerpoint/2010/main" val="591543114"/>
       </p:ext>
     </p:extLst>
   </p:cSld>

</xml_diff>